<commit_message>
docs: update data sources on slide 9 table to '한국관광공사 API'
</commit_message>
<xml_diff>
--- a/docs/Korean Regional Tourism Strategy Deck.pptx
+++ b/docs/Korean Regional Tourism Strategy Deck.pptx
@@ -18331,7 +18331,7 @@
                         </a:defRPr>
                       </a:pPr>
                       <a:r>
-                        <a:t>Klook, GetYourGuide, 크롤링</a:t>
+                        <a:t>한국관광공사 API</a:t>
                       </a:r>
                     </a:p>
                   </a:txBody>
@@ -18432,7 +18432,7 @@
                         </a:defRPr>
                       </a:pPr>
                       <a:r>
-                        <a:t>한국관광공사 ODCloud API</a:t>
+                        <a:t>한국관광공사 API</a:t>
                       </a:r>
                     </a:p>
                   </a:txBody>

</xml_diff>